<commit_message>
Fix equal technology slide shapes
</commit_message>
<xml_diff>
--- a/Data_Scraping_Project.pptx
+++ b/Data_Scraping_Project.pptx
@@ -4072,8 +4072,8 @@
         </p:nvSpPr>
         <p:spPr>
           <a:xfrm>
-            <a:off x="731520" y="1554480"/>
-            <a:ext cx="3383280" cy="3200400"/>
+            <a:off x="731520" y="1508760"/>
+            <a:ext cx="5212080" cy="2011680"/>
           </a:xfrm>
           <a:prstGeom prst="roundRect">
             <a:avLst/>
@@ -4117,8 +4117,8 @@
         </p:nvSpPr>
         <p:spPr>
           <a:xfrm>
-            <a:off x="960120" y="1783080"/>
-            <a:ext cx="2926080" cy="2743200"/>
+            <a:off x="960120" y="1737360"/>
+            <a:ext cx="4754880" cy="1554480"/>
           </a:xfrm>
           <a:prstGeom prst="rect">
             <a:avLst/>
@@ -4167,8 +4167,8 @@
         </p:nvSpPr>
         <p:spPr>
           <a:xfrm>
-            <a:off x="4389120" y="1554480"/>
-            <a:ext cx="3383280" cy="3200400"/>
+            <a:off x="6263640" y="1508760"/>
+            <a:ext cx="5212080" cy="2011680"/>
           </a:xfrm>
           <a:prstGeom prst="roundRect">
             <a:avLst/>
@@ -4212,8 +4212,8 @@
         </p:nvSpPr>
         <p:spPr>
           <a:xfrm>
-            <a:off x="4617720" y="1783080"/>
-            <a:ext cx="2926080" cy="2743200"/>
+            <a:off x="6492240" y="1737360"/>
+            <a:ext cx="4754880" cy="1554480"/>
           </a:xfrm>
           <a:prstGeom prst="rect">
             <a:avLst/>
@@ -4262,8 +4262,8 @@
         </p:nvSpPr>
         <p:spPr>
           <a:xfrm>
-            <a:off x="8046720" y="1554480"/>
-            <a:ext cx="3383280" cy="3200400"/>
+            <a:off x="731520" y="3886200"/>
+            <a:ext cx="5212080" cy="2011680"/>
           </a:xfrm>
           <a:prstGeom prst="roundRect">
             <a:avLst/>
@@ -4307,8 +4307,8 @@
         </p:nvSpPr>
         <p:spPr>
           <a:xfrm>
-            <a:off x="8275320" y="1783080"/>
-            <a:ext cx="2926080" cy="2743200"/>
+            <a:off x="960120" y="4114800"/>
+            <a:ext cx="4754880" cy="1554480"/>
           </a:xfrm>
           <a:prstGeom prst="rect">
             <a:avLst/>
@@ -4357,8 +4357,8 @@
         </p:nvSpPr>
         <p:spPr>
           <a:xfrm>
-            <a:off x="4389120" y="4800600"/>
-            <a:ext cx="3383280" cy="3200400"/>
+            <a:off x="6263640" y="3886200"/>
+            <a:ext cx="5212080" cy="2011680"/>
           </a:xfrm>
           <a:prstGeom prst="roundRect">
             <a:avLst/>
@@ -4402,8 +4402,8 @@
         </p:nvSpPr>
         <p:spPr>
           <a:xfrm>
-            <a:off x="4617720" y="5029200"/>
-            <a:ext cx="2926080" cy="2743200"/>
+            <a:off x="6492240" y="4114800"/>
+            <a:ext cx="4754880" cy="1554480"/>
           </a:xfrm>
           <a:prstGeom prst="rect">
             <a:avLst/>

</xml_diff>

<commit_message>
Polish technology slide layout
</commit_message>
<xml_diff>
--- a/Data_Scraping_Project.pptx
+++ b/Data_Scraping_Project.pptx
@@ -4072,16 +4072,16 @@
         </p:nvSpPr>
         <p:spPr>
           <a:xfrm>
-            <a:off x="731520" y="1508760"/>
+            <a:off x="731520" y="1554480"/>
             <a:ext cx="5212080" cy="2011680"/>
           </a:xfrm>
           <a:prstGeom prst="roundRect">
             <a:avLst/>
           </a:prstGeom>
           <a:solidFill>
-            <a:srgbClr val="EFF6F7"/>
+            <a:srgbClr val="E7F4F4"/>
           </a:solidFill>
-          <a:ln>
+          <a:ln w="15875">
             <a:solidFill>
               <a:srgbClr val="167D89"/>
             </a:solidFill>
@@ -4117,8 +4117,8 @@
         </p:nvSpPr>
         <p:spPr>
           <a:xfrm>
-            <a:off x="960120" y="1737360"/>
-            <a:ext cx="4754880" cy="1554480"/>
+            <a:off x="1051560" y="1874519"/>
+            <a:ext cx="4572000" cy="1371600"/>
           </a:xfrm>
           <a:prstGeom prst="rect">
             <a:avLst/>
@@ -4132,10 +4132,11 @@
           <a:lstStyle/>
           <a:p>
             <a:pPr>
-              <a:defRPr sz="2000" b="1">
-                <a:solidFill>
-                  <a:srgbClr val="167D89"/>
-                </a:solidFill>
+              <a:defRPr sz="2300" b="1">
+                <a:solidFill>
+                  <a:srgbClr val="182D48"/>
+                </a:solidFill>
+                <a:latin typeface="Aptos Display"/>
               </a:defRPr>
             </a:pPr>
             <a:r>
@@ -4145,16 +4146,17 @@
           <a:p>
             <a:pPr>
               <a:spcBef>
-                <a:spcPts val="1200"/>
+                <a:spcPts val="1000"/>
               </a:spcBef>
-              <a:defRPr sz="1600">
+              <a:defRPr sz="1700">
                 <a:solidFill>
                   <a:srgbClr val="26303A"/>
                 </a:solidFill>
+                <a:latin typeface="Aptos"/>
               </a:defRPr>
             </a:pPr>
             <a:r>
-              <a:t>Programming language used to build each scraper.</a:t>
+              <a:t>Builds the scraper programs.</a:t>
             </a:r>
           </a:p>
         </p:txBody>
@@ -4167,16 +4169,16 @@
         </p:nvSpPr>
         <p:spPr>
           <a:xfrm>
-            <a:off x="6263640" y="1508760"/>
+            <a:off x="6263640" y="1554480"/>
             <a:ext cx="5212080" cy="2011680"/>
           </a:xfrm>
           <a:prstGeom prst="roundRect">
             <a:avLst/>
           </a:prstGeom>
           <a:solidFill>
-            <a:srgbClr val="EFF6F7"/>
+            <a:srgbClr val="F6EFDA"/>
           </a:solidFill>
-          <a:ln>
+          <a:ln w="15875">
             <a:solidFill>
               <a:srgbClr val="167D89"/>
             </a:solidFill>
@@ -4212,8 +4214,8 @@
         </p:nvSpPr>
         <p:spPr>
           <a:xfrm>
-            <a:off x="6492240" y="1737360"/>
-            <a:ext cx="4754880" cy="1554480"/>
+            <a:off x="6583679" y="1874519"/>
+            <a:ext cx="4572000" cy="1371600"/>
           </a:xfrm>
           <a:prstGeom prst="rect">
             <a:avLst/>
@@ -4227,10 +4229,11 @@
           <a:lstStyle/>
           <a:p>
             <a:pPr>
-              <a:defRPr sz="2000" b="1">
-                <a:solidFill>
-                  <a:srgbClr val="167D89"/>
-                </a:solidFill>
+              <a:defRPr sz="2300" b="1">
+                <a:solidFill>
+                  <a:srgbClr val="182D48"/>
+                </a:solidFill>
+                <a:latin typeface="Aptos Display"/>
               </a:defRPr>
             </a:pPr>
             <a:r>
@@ -4240,16 +4243,17 @@
           <a:p>
             <a:pPr>
               <a:spcBef>
-                <a:spcPts val="1200"/>
+                <a:spcPts val="1000"/>
               </a:spcBef>
-              <a:defRPr sz="1600">
+              <a:defRPr sz="1700">
                 <a:solidFill>
                   <a:srgbClr val="26303A"/>
                 </a:solidFill>
+                <a:latin typeface="Aptos"/>
               </a:defRPr>
             </a:pPr>
             <a:r>
-              <a:t>Downloads HTML pages from the practice websites.</a:t>
+              <a:t>Downloads website HTML pages.</a:t>
             </a:r>
           </a:p>
         </p:txBody>
@@ -4269,9 +4273,9 @@
             <a:avLst/>
           </a:prstGeom>
           <a:solidFill>
-            <a:srgbClr val="EFF6F7"/>
+            <a:srgbClr val="ECF1F8"/>
           </a:solidFill>
-          <a:ln>
+          <a:ln w="15875">
             <a:solidFill>
               <a:srgbClr val="167D89"/>
             </a:solidFill>
@@ -4307,8 +4311,8 @@
         </p:nvSpPr>
         <p:spPr>
           <a:xfrm>
-            <a:off x="960120" y="4114800"/>
-            <a:ext cx="4754880" cy="1554480"/>
+            <a:off x="1051560" y="4206240"/>
+            <a:ext cx="4572000" cy="1371600"/>
           </a:xfrm>
           <a:prstGeom prst="rect">
             <a:avLst/>
@@ -4322,10 +4326,11 @@
           <a:lstStyle/>
           <a:p>
             <a:pPr>
-              <a:defRPr sz="2000" b="1">
-                <a:solidFill>
-                  <a:srgbClr val="167D89"/>
-                </a:solidFill>
+              <a:defRPr sz="2300" b="1">
+                <a:solidFill>
+                  <a:srgbClr val="182D48"/>
+                </a:solidFill>
+                <a:latin typeface="Aptos Display"/>
               </a:defRPr>
             </a:pPr>
             <a:r>
@@ -4335,16 +4340,17 @@
           <a:p>
             <a:pPr>
               <a:spcBef>
-                <a:spcPts val="1200"/>
+                <a:spcPts val="1000"/>
               </a:spcBef>
-              <a:defRPr sz="1600">
+              <a:defRPr sz="1700">
                 <a:solidFill>
                   <a:srgbClr val="26303A"/>
                 </a:solidFill>
+                <a:latin typeface="Aptos"/>
               </a:defRPr>
             </a:pPr>
             <a:r>
-              <a:t>Finds and extracts data from HTML elements.</a:t>
+              <a:t>Finds data inside HTML.</a:t>
             </a:r>
           </a:p>
         </p:txBody>
@@ -4364,9 +4370,9 @@
             <a:avLst/>
           </a:prstGeom>
           <a:solidFill>
-            <a:srgbClr val="EFF6F7"/>
+            <a:srgbClr val="F4EBEF"/>
           </a:solidFill>
-          <a:ln>
+          <a:ln w="15875">
             <a:solidFill>
               <a:srgbClr val="167D89"/>
             </a:solidFill>
@@ -4402,8 +4408,8 @@
         </p:nvSpPr>
         <p:spPr>
           <a:xfrm>
-            <a:off x="6492240" y="4114800"/>
-            <a:ext cx="4754880" cy="1554480"/>
+            <a:off x="6583679" y="4206240"/>
+            <a:ext cx="4572000" cy="1371600"/>
           </a:xfrm>
           <a:prstGeom prst="rect">
             <a:avLst/>
@@ -4417,10 +4423,11 @@
           <a:lstStyle/>
           <a:p>
             <a:pPr>
-              <a:defRPr sz="2000" b="1">
-                <a:solidFill>
-                  <a:srgbClr val="167D89"/>
-                </a:solidFill>
+              <a:defRPr sz="2300" b="1">
+                <a:solidFill>
+                  <a:srgbClr val="182D48"/>
+                </a:solidFill>
+                <a:latin typeface="Aptos Display"/>
               </a:defRPr>
             </a:pPr>
             <a:r>
@@ -4430,16 +4437,17 @@
           <a:p>
             <a:pPr>
               <a:spcBef>
-                <a:spcPts val="1200"/>
+                <a:spcPts val="1000"/>
               </a:spcBef>
-              <a:defRPr sz="1600">
+              <a:defRPr sz="1700">
                 <a:solidFill>
                   <a:srgbClr val="26303A"/>
                 </a:solidFill>
+                <a:latin typeface="Aptos"/>
               </a:defRPr>
             </a:pPr>
             <a:r>
-              <a:t>Stores records and exports them to CSV files.</a:t>
+              <a:t>Organizes data and creates CSV files.</a:t>
             </a:r>
           </a:p>
         </p:txBody>

</xml_diff>